<commit_message>
T-009 add red team sample exam corpus
</commit_message>
<xml_diff>
--- a/courseware/202612_ADS_W16_Review_Final_Machine_Exam.pptx
+++ b/courseware/202612_ADS_W16_Review_Final_Machine_Exam.pptx
@@ -19441,6 +19441,49 @@
                 <a:latin typeface="Segoe UI"/>
                 <a:ea typeface="微软雅黑"/>
               </a:rPr>
+              <a:t>•  ☐ </a:t>
+            </a:r>
+            <a:r>
+              <a:rPr sz="1879" b="0" i="0">
+                <a:solidFill>
+                  <a:srgbClr val="242A33"/>
+                </a:solidFill>
+                <a:latin typeface="Consolas"/>
+                <a:ea typeface="Consolas"/>
+              </a:rPr>
+              <a:t>tools/redteam_exam.py</a:t>
+            </a:r>
+            <a:r>
+              <a:rPr sz="2000" b="0" i="0">
+                <a:solidFill>
+                  <a:srgbClr val="242A33"/>
+                </a:solidFill>
+                <a:latin typeface="Segoe UI"/>
+                <a:ea typeface="微软雅黑"/>
+              </a:rPr>
+              <a:t> 已跑过 T1–T6 的 WA / TLE / MLE 反例</a:t>
+            </a:r>
+          </a:p>
+          <a:p>
+            <a:pPr algn="l">
+              <a:lnSpc>
+                <a:spcPct val="132000"/>
+              </a:lnSpc>
+              <a:spcBef>
+                <a:spcPts val="0"/>
+              </a:spcBef>
+              <a:spcAft>
+                <a:spcPts val="1240"/>
+              </a:spcAft>
+            </a:pPr>
+            <a:r>
+              <a:rPr sz="2000" b="0" i="0">
+                <a:solidFill>
+                  <a:srgbClr val="242A33"/>
+                </a:solidFill>
+                <a:latin typeface="Segoe UI"/>
+                <a:ea typeface="微软雅黑"/>
+              </a:rPr>
               <a:t>•  ☐ 时限按参考解答实测时间的 </a:t>
             </a:r>
             <a:r>

</xml_diff>

<commit_message>
courseware: remove fixed exam score allocation
</commit_message>
<xml_diff>
--- a/courseware/202612_ADS_W16_Review_Final_Machine_Exam.pptx
+++ b/courseware/202612_ADS_W16_Review_Final_Machine_Exam.pptx
@@ -6788,7 +6788,7 @@
                 <a:latin typeface="Segoe UI"/>
                 <a:ea typeface="微软雅黑"/>
               </a:rPr>
-              <a:t>T1 成绩单核对（15 分）★☆☆☆☆</a:t>
+              <a:t>T1 成绩单核对★☆☆☆☆</a:t>
             </a:r>
           </a:p>
         </p:txBody>
@@ -7987,7 +7987,7 @@
                 <a:latin typeface="Segoe UI"/>
                 <a:ea typeface="微软雅黑"/>
               </a:rPr>
-              <a:t>T2 括号嵌套深度（15 分）★★☆☆☆</a:t>
+              <a:t>T2 括号嵌套深度★★☆☆☆</a:t>
             </a:r>
           </a:p>
         </p:txBody>
@@ -9517,7 +9517,7 @@
                 <a:latin typeface="Segoe UI"/>
                 <a:ea typeface="微软雅黑"/>
               </a:rPr>
-              <a:t>T3 会议室数量（15 分）★★★☆☆</a:t>
+              <a:t>T3 会议室数量★★★☆☆</a:t>
             </a:r>
           </a:p>
         </p:txBody>
@@ -11461,7 +11461,7 @@
                 <a:latin typeface="Segoe UI"/>
                 <a:ea typeface="微软雅黑"/>
               </a:rPr>
-              <a:t>T4 穿墙迷宫（15 分）★★★☆☆</a:t>
+              <a:t>T4 穿墙迷宫★★★☆☆</a:t>
             </a:r>
           </a:p>
         </p:txBody>
@@ -13388,7 +13388,7 @@
                 <a:latin typeface="Segoe UI"/>
                 <a:ea typeface="微软雅黑"/>
               </a:rPr>
-              <a:t>T5 作业时间分配（20 分）★★★★☆</a:t>
+              <a:t>T5 作业时间分配★★★★☆</a:t>
             </a:r>
           </a:p>
         </p:txBody>
@@ -14653,7 +14653,7 @@
                 <a:latin typeface="Segoe UI"/>
                 <a:ea typeface="微软雅黑"/>
               </a:rPr>
-              <a:t>T6 电网巡检（20 分）★★★★★</a:t>
+              <a:t>T6 电网巡检★★★★★</a:t>
             </a:r>
           </a:p>
         </p:txBody>

</xml_diff>